<commit_message>
Update cavapy training contents
</commit_message>
<xml_diff>
--- a/STP/presentations/Survey/results_survey_ST.pptx
+++ b/STP/presentations/Survey/results_survey_ST.pptx
@@ -264,7 +264,7 @@
           <a:p>
             <a:fld id="{EEE01112-262A-2648-A829-0A10B0E34E16}" type="datetimeFigureOut">
               <a:rPr lang="en-IT" smtClean="0"/>
-              <a:t>04/12/25</a:t>
+              <a:t>12/04/2025</a:t>
             </a:fld>
             <a:endParaRPr lang="en-IT"/>
           </a:p>
@@ -464,7 +464,7 @@
           <a:p>
             <a:fld id="{EEE01112-262A-2648-A829-0A10B0E34E16}" type="datetimeFigureOut">
               <a:rPr lang="en-IT" smtClean="0"/>
-              <a:t>04/12/25</a:t>
+              <a:t>12/04/2025</a:t>
             </a:fld>
             <a:endParaRPr lang="en-IT"/>
           </a:p>
@@ -674,7 +674,7 @@
           <a:p>
             <a:fld id="{EEE01112-262A-2648-A829-0A10B0E34E16}" type="datetimeFigureOut">
               <a:rPr lang="en-IT" smtClean="0"/>
-              <a:t>04/12/25</a:t>
+              <a:t>12/04/2025</a:t>
             </a:fld>
             <a:endParaRPr lang="en-IT"/>
           </a:p>
@@ -874,7 +874,7 @@
           <a:p>
             <a:fld id="{EEE01112-262A-2648-A829-0A10B0E34E16}" type="datetimeFigureOut">
               <a:rPr lang="en-IT" smtClean="0"/>
-              <a:t>04/12/25</a:t>
+              <a:t>12/04/2025</a:t>
             </a:fld>
             <a:endParaRPr lang="en-IT"/>
           </a:p>
@@ -1150,7 +1150,7 @@
           <a:p>
             <a:fld id="{EEE01112-262A-2648-A829-0A10B0E34E16}" type="datetimeFigureOut">
               <a:rPr lang="en-IT" smtClean="0"/>
-              <a:t>04/12/25</a:t>
+              <a:t>12/04/2025</a:t>
             </a:fld>
             <a:endParaRPr lang="en-IT"/>
           </a:p>
@@ -1418,7 +1418,7 @@
           <a:p>
             <a:fld id="{EEE01112-262A-2648-A829-0A10B0E34E16}" type="datetimeFigureOut">
               <a:rPr lang="en-IT" smtClean="0"/>
-              <a:t>04/12/25</a:t>
+              <a:t>12/04/2025</a:t>
             </a:fld>
             <a:endParaRPr lang="en-IT"/>
           </a:p>
@@ -1833,7 +1833,7 @@
           <a:p>
             <a:fld id="{EEE01112-262A-2648-A829-0A10B0E34E16}" type="datetimeFigureOut">
               <a:rPr lang="en-IT" smtClean="0"/>
-              <a:t>04/12/25</a:t>
+              <a:t>12/04/2025</a:t>
             </a:fld>
             <a:endParaRPr lang="en-IT"/>
           </a:p>
@@ -1975,7 +1975,7 @@
           <a:p>
             <a:fld id="{EEE01112-262A-2648-A829-0A10B0E34E16}" type="datetimeFigureOut">
               <a:rPr lang="en-IT" smtClean="0"/>
-              <a:t>04/12/25</a:t>
+              <a:t>12/04/2025</a:t>
             </a:fld>
             <a:endParaRPr lang="en-IT"/>
           </a:p>
@@ -2088,7 +2088,7 @@
           <a:p>
             <a:fld id="{EEE01112-262A-2648-A829-0A10B0E34E16}" type="datetimeFigureOut">
               <a:rPr lang="en-IT" smtClean="0"/>
-              <a:t>04/12/25</a:t>
+              <a:t>12/04/2025</a:t>
             </a:fld>
             <a:endParaRPr lang="en-IT"/>
           </a:p>
@@ -2401,7 +2401,7 @@
           <a:p>
             <a:fld id="{EEE01112-262A-2648-A829-0A10B0E34E16}" type="datetimeFigureOut">
               <a:rPr lang="en-IT" smtClean="0"/>
-              <a:t>04/12/25</a:t>
+              <a:t>12/04/2025</a:t>
             </a:fld>
             <a:endParaRPr lang="en-IT"/>
           </a:p>
@@ -2690,7 +2690,7 @@
           <a:p>
             <a:fld id="{EEE01112-262A-2648-A829-0A10B0E34E16}" type="datetimeFigureOut">
               <a:rPr lang="en-IT" smtClean="0"/>
-              <a:t>04/12/25</a:t>
+              <a:t>12/04/2025</a:t>
             </a:fld>
             <a:endParaRPr lang="en-IT"/>
           </a:p>
@@ -2933,7 +2933,7 @@
           <a:p>
             <a:fld id="{EEE01112-262A-2648-A829-0A10B0E34E16}" type="datetimeFigureOut">
               <a:rPr lang="en-IT" smtClean="0"/>
-              <a:t>04/12/25</a:t>
+              <a:t>12/04/2025</a:t>
             </a:fld>
             <a:endParaRPr lang="en-IT"/>
           </a:p>
@@ -3878,10 +3878,10 @@
       </p:pic>
       <p:sp>
         <p:nvSpPr>
-          <p:cNvPr id="6" name="TextBox 5">
-            <a:extLst>
-              <a:ext uri="{FF2B5EF4-FFF2-40B4-BE49-F238E27FC236}">
-                <a16:creationId xmlns:a16="http://schemas.microsoft.com/office/drawing/2014/main" id="{3AFF9606-8124-ECBC-461A-02DDD0789D6D}"/>
+          <p:cNvPr id="2" name="TextBox 1">
+            <a:extLst>
+              <a:ext uri="{FF2B5EF4-FFF2-40B4-BE49-F238E27FC236}">
+                <a16:creationId xmlns:a16="http://schemas.microsoft.com/office/drawing/2014/main" id="{596E914C-33E9-591B-E8E3-3C27080C7157}"/>
               </a:ext>
             </a:extLst>
           </p:cNvPr>
@@ -3890,500 +3890,8 @@
         </p:nvSpPr>
         <p:spPr>
           <a:xfrm>
-            <a:off x="6836735" y="818707"/>
-            <a:ext cx="4380614" cy="646331"/>
-          </a:xfrm>
-          <a:prstGeom prst="rect">
-            <a:avLst/>
-          </a:prstGeom>
-          <a:noFill/>
-          <a:ln w="25400">
-            <a:solidFill>
-              <a:srgbClr val="FF0000"/>
-            </a:solidFill>
-          </a:ln>
-        </p:spPr>
-        <p:txBody>
-          <a:bodyPr wrap="square" rtlCol="0">
-            <a:spAutoFit/>
-          </a:bodyPr>
-          <a:lstStyle/>
-          <a:p>
-            <a:r>
-              <a:rPr lang="en-GB" dirty="0"/>
-              <a:t>A</a:t>
-            </a:r>
-            <a:r>
-              <a:rPr lang="en-IT" dirty="0"/>
-              <a:t>ctivity_14=</a:t>
-            </a:r>
-            <a:r>
-              <a:rPr lang="en-GB" dirty="0" err="1"/>
-              <a:t>construção</a:t>
-            </a:r>
-            <a:r>
-              <a:rPr lang="en-GB" dirty="0"/>
-              <a:t> de </a:t>
-            </a:r>
-            <a:r>
-              <a:rPr lang="en-GB" dirty="0" err="1"/>
-              <a:t>valas</a:t>
-            </a:r>
-            <a:r>
-              <a:rPr lang="en-GB" dirty="0"/>
-              <a:t> de </a:t>
-            </a:r>
-            <a:r>
-              <a:rPr lang="en-GB" dirty="0" err="1"/>
-              <a:t>drenagem</a:t>
-            </a:r>
-            <a:r>
-              <a:rPr lang="en-GB" dirty="0"/>
-              <a:t> e </a:t>
-            </a:r>
-            <a:r>
-              <a:rPr lang="en-GB" dirty="0" err="1"/>
-              <a:t>reservatórios</a:t>
-            </a:r>
-            <a:r>
-              <a:rPr lang="en-GB" dirty="0"/>
-              <a:t> de </a:t>
-            </a:r>
-            <a:r>
-              <a:rPr lang="en-GB" dirty="0" err="1"/>
-              <a:t>água</a:t>
-            </a:r>
-            <a:endParaRPr lang="en-IT" dirty="0"/>
-          </a:p>
-        </p:txBody>
-      </p:sp>
-      <p:sp>
-        <p:nvSpPr>
-          <p:cNvPr id="7" name="TextBox 6">
-            <a:extLst>
-              <a:ext uri="{FF2B5EF4-FFF2-40B4-BE49-F238E27FC236}">
-                <a16:creationId xmlns:a16="http://schemas.microsoft.com/office/drawing/2014/main" id="{670E026B-3537-673E-F061-E6B26389F7AD}"/>
-              </a:ext>
-            </a:extLst>
-          </p:cNvPr>
-          <p:cNvSpPr txBox="1"/>
-          <p:nvPr/>
-        </p:nvSpPr>
-        <p:spPr>
-          <a:xfrm>
-            <a:off x="6836735" y="1633716"/>
-            <a:ext cx="4380614" cy="646331"/>
-          </a:xfrm>
-          <a:prstGeom prst="rect">
-            <a:avLst/>
-          </a:prstGeom>
-          <a:solidFill>
-            <a:schemeClr val="bg1"/>
-          </a:solidFill>
-          <a:ln w="25400">
-            <a:solidFill>
-              <a:srgbClr val="FF0000"/>
-            </a:solidFill>
-          </a:ln>
-        </p:spPr>
-        <p:txBody>
-          <a:bodyPr wrap="square" rtlCol="0">
-            <a:spAutoFit/>
-          </a:bodyPr>
-          <a:lstStyle/>
-          <a:p>
-            <a:r>
-              <a:rPr lang="en-GB" dirty="0"/>
-              <a:t>A</a:t>
-            </a:r>
-            <a:r>
-              <a:rPr lang="en-IT" dirty="0"/>
-              <a:t>ctivity_11=</a:t>
-            </a:r>
-            <a:r>
-              <a:rPr lang="en-GB" dirty="0" err="1"/>
-              <a:t>Estabelecimento</a:t>
-            </a:r>
-            <a:r>
-              <a:rPr lang="en-GB" dirty="0"/>
-              <a:t> de um Sistema de </a:t>
-            </a:r>
-            <a:r>
-              <a:rPr lang="en-GB" dirty="0" err="1"/>
-              <a:t>Alerta</a:t>
-            </a:r>
-            <a:r>
-              <a:rPr lang="en-GB" dirty="0"/>
-              <a:t> </a:t>
-            </a:r>
-            <a:r>
-              <a:rPr lang="en-GB" dirty="0" err="1"/>
-              <a:t>Climático</a:t>
-            </a:r>
-            <a:endParaRPr lang="en-IT" dirty="0"/>
-          </a:p>
-        </p:txBody>
-      </p:sp>
-      <p:sp>
-        <p:nvSpPr>
-          <p:cNvPr id="8" name="TextBox 7">
-            <a:extLst>
-              <a:ext uri="{FF2B5EF4-FFF2-40B4-BE49-F238E27FC236}">
-                <a16:creationId xmlns:a16="http://schemas.microsoft.com/office/drawing/2014/main" id="{CE69A639-F2B0-DB0F-367A-43E418182B2B}"/>
-              </a:ext>
-            </a:extLst>
-          </p:cNvPr>
-          <p:cNvSpPr txBox="1"/>
-          <p:nvPr/>
-        </p:nvSpPr>
-        <p:spPr>
-          <a:xfrm>
-            <a:off x="6836735" y="2782669"/>
-            <a:ext cx="4380614" cy="646331"/>
-          </a:xfrm>
-          <a:prstGeom prst="rect">
-            <a:avLst/>
-          </a:prstGeom>
-          <a:solidFill>
-            <a:schemeClr val="bg1"/>
-          </a:solidFill>
-          <a:ln w="25400">
-            <a:solidFill>
-              <a:schemeClr val="accent5">
-                <a:lumMod val="60000"/>
-                <a:lumOff val="40000"/>
-              </a:schemeClr>
-            </a:solidFill>
-          </a:ln>
-        </p:spPr>
-        <p:txBody>
-          <a:bodyPr wrap="square" rtlCol="0">
-            <a:spAutoFit/>
-          </a:bodyPr>
-          <a:lstStyle/>
-          <a:p>
-            <a:r>
-              <a:rPr lang="en-GB" dirty="0"/>
-              <a:t>A</a:t>
-            </a:r>
-            <a:r>
-              <a:rPr lang="en-IT" dirty="0"/>
-              <a:t>ctivity_6=</a:t>
-            </a:r>
-            <a:r>
-              <a:rPr lang="en-GB" dirty="0" err="1"/>
-              <a:t>Estabelecimento</a:t>
-            </a:r>
-            <a:r>
-              <a:rPr lang="en-GB" dirty="0"/>
-              <a:t> e </a:t>
-            </a:r>
-            <a:r>
-              <a:rPr lang="en-GB" dirty="0" err="1"/>
-              <a:t>Fiscalização</a:t>
-            </a:r>
-            <a:r>
-              <a:rPr lang="en-GB" dirty="0"/>
-              <a:t> de </a:t>
-            </a:r>
-            <a:r>
-              <a:rPr lang="en-GB" dirty="0" err="1"/>
-              <a:t>Áreas</a:t>
-            </a:r>
-            <a:r>
-              <a:rPr lang="en-GB" dirty="0"/>
-              <a:t> </a:t>
-            </a:r>
-            <a:r>
-              <a:rPr lang="en-GB" dirty="0" err="1"/>
-              <a:t>Marinhas</a:t>
-            </a:r>
-            <a:r>
-              <a:rPr lang="en-GB" dirty="0"/>
-              <a:t> </a:t>
-            </a:r>
-            <a:r>
-              <a:rPr lang="en-GB" dirty="0" err="1"/>
-              <a:t>Protegidas</a:t>
-            </a:r>
-            <a:endParaRPr lang="en-IT" dirty="0"/>
-          </a:p>
-        </p:txBody>
-      </p:sp>
-      <p:sp>
-        <p:nvSpPr>
-          <p:cNvPr id="9" name="TextBox 8">
-            <a:extLst>
-              <a:ext uri="{FF2B5EF4-FFF2-40B4-BE49-F238E27FC236}">
-                <a16:creationId xmlns:a16="http://schemas.microsoft.com/office/drawing/2014/main" id="{46CBC91C-6340-C728-8FBC-27DE4C8ED113}"/>
-              </a:ext>
-            </a:extLst>
-          </p:cNvPr>
-          <p:cNvSpPr txBox="1"/>
-          <p:nvPr/>
-        </p:nvSpPr>
-        <p:spPr>
-          <a:xfrm>
-            <a:off x="6836735" y="3730199"/>
-            <a:ext cx="4380614" cy="646331"/>
-          </a:xfrm>
-          <a:prstGeom prst="rect">
-            <a:avLst/>
-          </a:prstGeom>
-          <a:solidFill>
-            <a:schemeClr val="bg1"/>
-          </a:solidFill>
-          <a:ln w="25400">
-            <a:solidFill>
-              <a:schemeClr val="accent5">
-                <a:lumMod val="60000"/>
-                <a:lumOff val="40000"/>
-              </a:schemeClr>
-            </a:solidFill>
-          </a:ln>
-        </p:spPr>
-        <p:txBody>
-          <a:bodyPr wrap="square" rtlCol="0">
-            <a:spAutoFit/>
-          </a:bodyPr>
-          <a:lstStyle/>
-          <a:p>
-            <a:r>
-              <a:rPr lang="en-GB" dirty="0"/>
-              <a:t>A</a:t>
-            </a:r>
-            <a:r>
-              <a:rPr lang="en-IT" dirty="0"/>
-              <a:t>ctivity_8=</a:t>
-            </a:r>
-            <a:r>
-              <a:rPr lang="en-GB" dirty="0" err="1"/>
-              <a:t>Estrutura</a:t>
-            </a:r>
-            <a:r>
-              <a:rPr lang="en-GB" dirty="0"/>
-              <a:t> </a:t>
-            </a:r>
-            <a:r>
-              <a:rPr lang="en-GB" dirty="0" err="1"/>
-              <a:t>regulatória</a:t>
-            </a:r>
-            <a:r>
-              <a:rPr lang="en-GB" dirty="0"/>
-              <a:t> para </a:t>
-            </a:r>
-            <a:r>
-              <a:rPr lang="en-GB" dirty="0" err="1"/>
-              <a:t>evitar</a:t>
-            </a:r>
-            <a:r>
-              <a:rPr lang="en-GB" dirty="0"/>
-              <a:t> a </a:t>
-            </a:r>
-            <a:r>
-              <a:rPr lang="en-GB" dirty="0" err="1"/>
-              <a:t>sobrepesca</a:t>
-            </a:r>
-            <a:endParaRPr lang="en-IT" dirty="0"/>
-          </a:p>
-        </p:txBody>
-      </p:sp>
-      <p:sp>
-        <p:nvSpPr>
-          <p:cNvPr id="10" name="TextBox 9">
-            <a:extLst>
-              <a:ext uri="{FF2B5EF4-FFF2-40B4-BE49-F238E27FC236}">
-                <a16:creationId xmlns:a16="http://schemas.microsoft.com/office/drawing/2014/main" id="{11FF4275-C236-65AE-4195-D05110126B03}"/>
-              </a:ext>
-            </a:extLst>
-          </p:cNvPr>
-          <p:cNvSpPr txBox="1"/>
-          <p:nvPr/>
-        </p:nvSpPr>
-        <p:spPr>
-          <a:xfrm>
-            <a:off x="6836735" y="4677729"/>
-            <a:ext cx="4380614" cy="646331"/>
-          </a:xfrm>
-          <a:prstGeom prst="rect">
-            <a:avLst/>
-          </a:prstGeom>
-          <a:solidFill>
-            <a:schemeClr val="bg1"/>
-          </a:solidFill>
-          <a:ln w="25400">
-            <a:solidFill>
-              <a:schemeClr val="tx2">
-                <a:lumMod val="75000"/>
-                <a:lumOff val="25000"/>
-              </a:schemeClr>
-            </a:solidFill>
-          </a:ln>
-        </p:spPr>
-        <p:txBody>
-          <a:bodyPr wrap="square" rtlCol="0">
-            <a:spAutoFit/>
-          </a:bodyPr>
-          <a:lstStyle/>
-          <a:p>
-            <a:r>
-              <a:rPr lang="en-GB" dirty="0"/>
-              <a:t>A</a:t>
-            </a:r>
-            <a:r>
-              <a:rPr lang="en-IT" dirty="0"/>
-              <a:t>ctivity_3=</a:t>
-            </a:r>
-            <a:r>
-              <a:rPr lang="en-GB" dirty="0" err="1"/>
-              <a:t>Construção</a:t>
-            </a:r>
-            <a:r>
-              <a:rPr lang="en-GB" dirty="0"/>
-              <a:t> de </a:t>
-            </a:r>
-            <a:r>
-              <a:rPr lang="en-GB" dirty="0" err="1"/>
-              <a:t>uma</a:t>
-            </a:r>
-            <a:r>
-              <a:rPr lang="en-GB" dirty="0"/>
-              <a:t> </a:t>
-            </a:r>
-            <a:r>
-              <a:rPr lang="en-GB" dirty="0" err="1"/>
-              <a:t>oficina</a:t>
-            </a:r>
-            <a:r>
-              <a:rPr lang="en-GB" dirty="0"/>
-              <a:t> para </a:t>
-            </a:r>
-            <a:r>
-              <a:rPr lang="en-GB" dirty="0" err="1"/>
-              <a:t>barcos</a:t>
-            </a:r>
-            <a:r>
-              <a:rPr lang="en-GB" dirty="0"/>
-              <a:t> de </a:t>
-            </a:r>
-            <a:r>
-              <a:rPr lang="en-GB" dirty="0" err="1"/>
-              <a:t>pesca</a:t>
-            </a:r>
-            <a:endParaRPr lang="en-IT" dirty="0"/>
-          </a:p>
-        </p:txBody>
-      </p:sp>
-      <p:sp>
-        <p:nvSpPr>
-          <p:cNvPr id="11" name="TextBox 10">
-            <a:extLst>
-              <a:ext uri="{FF2B5EF4-FFF2-40B4-BE49-F238E27FC236}">
-                <a16:creationId xmlns:a16="http://schemas.microsoft.com/office/drawing/2014/main" id="{661D2A94-7E2D-0460-FD4D-F50168418155}"/>
-              </a:ext>
-            </a:extLst>
-          </p:cNvPr>
-          <p:cNvSpPr txBox="1"/>
-          <p:nvPr/>
-        </p:nvSpPr>
-        <p:spPr>
-          <a:xfrm>
-            <a:off x="6836735" y="5625259"/>
-            <a:ext cx="4380614" cy="923330"/>
-          </a:xfrm>
-          <a:prstGeom prst="rect">
-            <a:avLst/>
-          </a:prstGeom>
-          <a:solidFill>
-            <a:schemeClr val="bg1"/>
-          </a:solidFill>
-          <a:ln w="25400">
-            <a:solidFill>
-              <a:schemeClr val="tx2">
-                <a:lumMod val="75000"/>
-                <a:lumOff val="25000"/>
-              </a:schemeClr>
-            </a:solidFill>
-          </a:ln>
-        </p:spPr>
-        <p:txBody>
-          <a:bodyPr wrap="square" rtlCol="0">
-            <a:spAutoFit/>
-          </a:bodyPr>
-          <a:lstStyle/>
-          <a:p>
-            <a:r>
-              <a:rPr lang="en-GB" dirty="0"/>
-              <a:t>A</a:t>
-            </a:r>
-            <a:r>
-              <a:rPr lang="en-IT" dirty="0"/>
-              <a:t>ctivity_2=</a:t>
-            </a:r>
-            <a:r>
-              <a:rPr lang="en-GB" dirty="0" err="1"/>
-              <a:t>Construção</a:t>
-            </a:r>
-            <a:r>
-              <a:rPr lang="en-GB" dirty="0"/>
-              <a:t> de mercados </a:t>
-            </a:r>
-            <a:r>
-              <a:rPr lang="en-GB" dirty="0" err="1"/>
-              <a:t>varejistas</a:t>
-            </a:r>
-            <a:r>
-              <a:rPr lang="en-GB" dirty="0"/>
-              <a:t> com </a:t>
-            </a:r>
-            <a:r>
-              <a:rPr lang="en-GB" dirty="0" err="1"/>
-              <a:t>armazenamento</a:t>
-            </a:r>
-            <a:r>
-              <a:rPr lang="en-GB" dirty="0"/>
-              <a:t> </a:t>
-            </a:r>
-            <a:r>
-              <a:rPr lang="en-GB" dirty="0" err="1"/>
-              <a:t>refrigerado</a:t>
-            </a:r>
-            <a:r>
-              <a:rPr lang="en-GB" dirty="0"/>
-              <a:t> e </a:t>
-            </a:r>
-            <a:r>
-              <a:rPr lang="en-GB" dirty="0" err="1"/>
-              <a:t>higiene</a:t>
-            </a:r>
-            <a:r>
-              <a:rPr lang="en-GB" dirty="0"/>
-              <a:t> de </a:t>
-            </a:r>
-            <a:r>
-              <a:rPr lang="en-GB" dirty="0" err="1"/>
-              <a:t>preparação</a:t>
-            </a:r>
-            <a:endParaRPr lang="en-IT" dirty="0"/>
-          </a:p>
-        </p:txBody>
-      </p:sp>
-      <p:sp>
-        <p:nvSpPr>
-          <p:cNvPr id="12" name="TextBox 11">
-            <a:extLst>
-              <a:ext uri="{FF2B5EF4-FFF2-40B4-BE49-F238E27FC236}">
-                <a16:creationId xmlns:a16="http://schemas.microsoft.com/office/drawing/2014/main" id="{01F12CFC-CF51-E138-282D-902011D9068F}"/>
-              </a:ext>
-            </a:extLst>
-          </p:cNvPr>
-          <p:cNvSpPr txBox="1"/>
-          <p:nvPr/>
-        </p:nvSpPr>
-        <p:spPr>
-          <a:xfrm>
-            <a:off x="5791200" y="1034150"/>
-            <a:ext cx="808381" cy="584775"/>
+            <a:off x="6753331" y="603262"/>
+            <a:ext cx="4742187" cy="923330"/>
           </a:xfrm>
           <a:prstGeom prst="rect">
             <a:avLst/>
@@ -4397,18 +3905,26 @@
           <a:lstStyle/>
           <a:p>
             <a:r>
-              <a:rPr lang="en-IT" sz="3200" dirty="0"/>
-              <a:t>*</a:t>
-            </a:r>
-          </a:p>
-        </p:txBody>
-      </p:sp>
-      <p:sp>
-        <p:nvSpPr>
-          <p:cNvPr id="13" name="TextBox 12">
-            <a:extLst>
-              <a:ext uri="{FF2B5EF4-FFF2-40B4-BE49-F238E27FC236}">
-                <a16:creationId xmlns:a16="http://schemas.microsoft.com/office/drawing/2014/main" id="{D5465866-5D18-2D95-D817-7F579435038B}"/>
+              <a:rPr lang="pt-BR" dirty="0"/>
+              <a:t>13/18 sugestões de adaptação &gt; média 4</a:t>
+            </a:r>
+          </a:p>
+          <a:p>
+            <a:r>
+              <a:rPr lang="pt-BR" dirty="0"/>
+              <a:t>
+Categoria mais popular: Defesas costeiras</a:t>
+            </a:r>
+            <a:endParaRPr lang="en-GB" dirty="0"/>
+          </a:p>
+        </p:txBody>
+      </p:sp>
+      <p:sp>
+        <p:nvSpPr>
+          <p:cNvPr id="3" name="TextBox 2">
+            <a:extLst>
+              <a:ext uri="{FF2B5EF4-FFF2-40B4-BE49-F238E27FC236}">
+                <a16:creationId xmlns:a16="http://schemas.microsoft.com/office/drawing/2014/main" id="{E4033363-88B0-505B-D61A-BCDC5ECDE887}"/>
               </a:ext>
             </a:extLst>
           </p:cNvPr>
@@ -4417,8 +3933,8 @@
         </p:nvSpPr>
         <p:spPr>
           <a:xfrm>
-            <a:off x="4982819" y="4979214"/>
-            <a:ext cx="808381" cy="584775"/>
+            <a:off x="6753331" y="1987659"/>
+            <a:ext cx="5154789" cy="3416320"/>
           </a:xfrm>
           <a:prstGeom prst="rect">
             <a:avLst/>
@@ -4432,79 +3948,67 @@
           <a:lstStyle/>
           <a:p>
             <a:r>
-              <a:rPr lang="en-IT" sz="3200" dirty="0"/>
-              <a:t>*</a:t>
-            </a:r>
-          </a:p>
-        </p:txBody>
-      </p:sp>
-      <p:sp>
-        <p:nvSpPr>
-          <p:cNvPr id="14" name="TextBox 13">
-            <a:extLst>
-              <a:ext uri="{FF2B5EF4-FFF2-40B4-BE49-F238E27FC236}">
-                <a16:creationId xmlns:a16="http://schemas.microsoft.com/office/drawing/2014/main" id="{A57036C4-101E-D4E5-5250-3D8E42AE24DC}"/>
-              </a:ext>
-            </a:extLst>
-          </p:cNvPr>
-          <p:cNvSpPr txBox="1"/>
-          <p:nvPr/>
-        </p:nvSpPr>
-        <p:spPr>
-          <a:xfrm>
-            <a:off x="5657986" y="1987659"/>
-            <a:ext cx="808381" cy="584775"/>
-          </a:xfrm>
-          <a:prstGeom prst="rect">
-            <a:avLst/>
-          </a:prstGeom>
-          <a:noFill/>
-        </p:spPr>
-        <p:txBody>
-          <a:bodyPr wrap="square" rtlCol="0">
-            <a:spAutoFit/>
-          </a:bodyPr>
-          <a:lstStyle/>
-          <a:p>
-            <a:r>
-              <a:rPr lang="en-IT" sz="3200" dirty="0"/>
-              <a:t>*</a:t>
-            </a:r>
-          </a:p>
-        </p:txBody>
-      </p:sp>
-      <p:sp>
-        <p:nvSpPr>
-          <p:cNvPr id="15" name="TextBox 14">
-            <a:extLst>
-              <a:ext uri="{FF2B5EF4-FFF2-40B4-BE49-F238E27FC236}">
-                <a16:creationId xmlns:a16="http://schemas.microsoft.com/office/drawing/2014/main" id="{687CB221-7072-8A4A-C930-A9586B0E7776}"/>
-              </a:ext>
-            </a:extLst>
-          </p:cNvPr>
-          <p:cNvSpPr txBox="1"/>
-          <p:nvPr/>
-        </p:nvSpPr>
-        <p:spPr>
-          <a:xfrm>
-            <a:off x="5657985" y="2421503"/>
-            <a:ext cx="808381" cy="584775"/>
-          </a:xfrm>
-          <a:prstGeom prst="rect">
-            <a:avLst/>
-          </a:prstGeom>
-          <a:noFill/>
-        </p:spPr>
-        <p:txBody>
-          <a:bodyPr wrap="square" rtlCol="0">
-            <a:spAutoFit/>
-          </a:bodyPr>
-          <a:lstStyle/>
-          <a:p>
-            <a:r>
-              <a:rPr lang="en-IT" sz="3200" dirty="0"/>
-              <a:t>*</a:t>
-            </a:r>
+              <a:rPr lang="pt-BR" dirty="0"/>
+              <a:t>Sugestões mais populares:</a:t>
+            </a:r>
+          </a:p>
+          <a:p>
+            <a:pPr marL="342900" indent="-342900">
+              <a:buFont typeface="+mj-lt"/>
+              <a:buAutoNum type="arabicPeriod"/>
+            </a:pPr>
+            <a:r>
+              <a:rPr lang="pt-BR" dirty="0"/>
+              <a:t>Construção de valas de drenagem e reservatórios de água</a:t>
+            </a:r>
+          </a:p>
+          <a:p>
+            <a:pPr marL="342900" indent="-342900">
+              <a:buFont typeface="+mj-lt"/>
+              <a:buAutoNum type="arabicPeriod"/>
+            </a:pPr>
+            <a:r>
+              <a:rPr lang="pt-BR" dirty="0"/>
+              <a:t>Estabelecimento de um sistema de alerta climático sobre o estado do mar</a:t>
+            </a:r>
+          </a:p>
+          <a:p>
+            <a:pPr marL="342900" indent="-342900">
+              <a:buFont typeface="+mj-lt"/>
+              <a:buAutoNum type="arabicPeriod"/>
+            </a:pPr>
+            <a:r>
+              <a:rPr lang="pt-BR" dirty="0"/>
+              <a:t>Desenvolvimento e fiscalização de áreas marinhas protegidas</a:t>
+            </a:r>
+          </a:p>
+          <a:p>
+            <a:endParaRPr lang="pt-BR" dirty="0"/>
+          </a:p>
+          <a:p>
+            <a:r>
+              <a:rPr lang="pt-BR" dirty="0"/>
+              <a:t>Menos popular:</a:t>
+            </a:r>
+          </a:p>
+          <a:p>
+            <a:pPr marL="342900" indent="-342900">
+              <a:buAutoNum type="arabicPeriod"/>
+            </a:pPr>
+            <a:r>
+              <a:rPr lang="pt-BR" dirty="0"/>
+              <a:t>Uso responsável de dispositivos de agregação de peixes ancorados (FADs).</a:t>
+            </a:r>
+          </a:p>
+          <a:p>
+            <a:pPr marL="342900" indent="-342900">
+              <a:buAutoNum type="arabicPeriod"/>
+            </a:pPr>
+            <a:r>
+              <a:rPr lang="pt-BR" dirty="0"/>
+              <a:t>Quadro regulatório para evitar a sobrepesca</a:t>
+            </a:r>
+            <a:endParaRPr lang="en-GB" dirty="0"/>
           </a:p>
         </p:txBody>
       </p:sp>
@@ -5048,533 +4552,6 @@
       </p:grpSpPr>
       <p:sp>
         <p:nvSpPr>
-          <p:cNvPr id="6" name="TextBox 5">
-            <a:extLst>
-              <a:ext uri="{FF2B5EF4-FFF2-40B4-BE49-F238E27FC236}">
-                <a16:creationId xmlns:a16="http://schemas.microsoft.com/office/drawing/2014/main" id="{131685BD-97E2-AD3A-08C7-07C5132783E4}"/>
-              </a:ext>
-            </a:extLst>
-          </p:cNvPr>
-          <p:cNvSpPr txBox="1"/>
-          <p:nvPr/>
-        </p:nvSpPr>
-        <p:spPr>
-          <a:xfrm>
-            <a:off x="6836735" y="818707"/>
-            <a:ext cx="4380614" cy="646331"/>
-          </a:xfrm>
-          <a:prstGeom prst="rect">
-            <a:avLst/>
-          </a:prstGeom>
-          <a:noFill/>
-          <a:ln w="25400">
-            <a:solidFill>
-              <a:srgbClr val="FF0000"/>
-            </a:solidFill>
-          </a:ln>
-        </p:spPr>
-        <p:txBody>
-          <a:bodyPr wrap="square" rtlCol="0">
-            <a:spAutoFit/>
-          </a:bodyPr>
-          <a:lstStyle/>
-          <a:p>
-            <a:r>
-              <a:rPr lang="en-GB" dirty="0"/>
-              <a:t>A</a:t>
-            </a:r>
-            <a:r>
-              <a:rPr lang="en-IT" dirty="0"/>
-              <a:t>ctivity_14=</a:t>
-            </a:r>
-            <a:r>
-              <a:rPr lang="en-GB" dirty="0" err="1"/>
-              <a:t>construção</a:t>
-            </a:r>
-            <a:r>
-              <a:rPr lang="en-GB" dirty="0"/>
-              <a:t> de </a:t>
-            </a:r>
-            <a:r>
-              <a:rPr lang="en-GB" dirty="0" err="1"/>
-              <a:t>valas</a:t>
-            </a:r>
-            <a:r>
-              <a:rPr lang="en-GB" dirty="0"/>
-              <a:t> de </a:t>
-            </a:r>
-            <a:r>
-              <a:rPr lang="en-GB" dirty="0" err="1"/>
-              <a:t>drenagem</a:t>
-            </a:r>
-            <a:r>
-              <a:rPr lang="en-GB" dirty="0"/>
-              <a:t> e </a:t>
-            </a:r>
-            <a:r>
-              <a:rPr lang="en-GB" dirty="0" err="1"/>
-              <a:t>reservatórios</a:t>
-            </a:r>
-            <a:r>
-              <a:rPr lang="en-GB" dirty="0"/>
-              <a:t> de </a:t>
-            </a:r>
-            <a:r>
-              <a:rPr lang="en-GB" dirty="0" err="1"/>
-              <a:t>água</a:t>
-            </a:r>
-            <a:endParaRPr lang="en-IT" dirty="0"/>
-          </a:p>
-        </p:txBody>
-      </p:sp>
-      <p:sp>
-        <p:nvSpPr>
-          <p:cNvPr id="7" name="TextBox 6">
-            <a:extLst>
-              <a:ext uri="{FF2B5EF4-FFF2-40B4-BE49-F238E27FC236}">
-                <a16:creationId xmlns:a16="http://schemas.microsoft.com/office/drawing/2014/main" id="{4E5EFAAF-10E6-EB29-AA88-CD653BBB0DF4}"/>
-              </a:ext>
-            </a:extLst>
-          </p:cNvPr>
-          <p:cNvSpPr txBox="1"/>
-          <p:nvPr/>
-        </p:nvSpPr>
-        <p:spPr>
-          <a:xfrm>
-            <a:off x="6836735" y="1633716"/>
-            <a:ext cx="4380614" cy="646331"/>
-          </a:xfrm>
-          <a:prstGeom prst="rect">
-            <a:avLst/>
-          </a:prstGeom>
-          <a:solidFill>
-            <a:schemeClr val="bg1"/>
-          </a:solidFill>
-          <a:ln w="25400">
-            <a:solidFill>
-              <a:srgbClr val="FF0000"/>
-            </a:solidFill>
-          </a:ln>
-        </p:spPr>
-        <p:txBody>
-          <a:bodyPr wrap="square" rtlCol="0">
-            <a:spAutoFit/>
-          </a:bodyPr>
-          <a:lstStyle/>
-          <a:p>
-            <a:r>
-              <a:rPr lang="en-GB" dirty="0"/>
-              <a:t>A</a:t>
-            </a:r>
-            <a:r>
-              <a:rPr lang="en-IT" dirty="0"/>
-              <a:t>ctivity_11=</a:t>
-            </a:r>
-            <a:r>
-              <a:rPr lang="en-GB" dirty="0" err="1"/>
-              <a:t>Estabelecimento</a:t>
-            </a:r>
-            <a:r>
-              <a:rPr lang="en-GB" dirty="0"/>
-              <a:t> de um Sistema de </a:t>
-            </a:r>
-            <a:r>
-              <a:rPr lang="en-GB" dirty="0" err="1"/>
-              <a:t>Alerta</a:t>
-            </a:r>
-            <a:r>
-              <a:rPr lang="en-GB" dirty="0"/>
-              <a:t> </a:t>
-            </a:r>
-            <a:r>
-              <a:rPr lang="en-GB" dirty="0" err="1"/>
-              <a:t>Climático</a:t>
-            </a:r>
-            <a:endParaRPr lang="en-IT" dirty="0"/>
-          </a:p>
-        </p:txBody>
-      </p:sp>
-      <p:sp>
-        <p:nvSpPr>
-          <p:cNvPr id="8" name="TextBox 7">
-            <a:extLst>
-              <a:ext uri="{FF2B5EF4-FFF2-40B4-BE49-F238E27FC236}">
-                <a16:creationId xmlns:a16="http://schemas.microsoft.com/office/drawing/2014/main" id="{5CC87ADB-6D38-DD3F-F0AC-2FFFC7BF6642}"/>
-              </a:ext>
-            </a:extLst>
-          </p:cNvPr>
-          <p:cNvSpPr txBox="1"/>
-          <p:nvPr/>
-        </p:nvSpPr>
-        <p:spPr>
-          <a:xfrm>
-            <a:off x="6836735" y="2782669"/>
-            <a:ext cx="4380614" cy="646331"/>
-          </a:xfrm>
-          <a:prstGeom prst="rect">
-            <a:avLst/>
-          </a:prstGeom>
-          <a:solidFill>
-            <a:schemeClr val="bg1"/>
-          </a:solidFill>
-          <a:ln w="25400">
-            <a:solidFill>
-              <a:schemeClr val="accent5">
-                <a:lumMod val="60000"/>
-                <a:lumOff val="40000"/>
-              </a:schemeClr>
-            </a:solidFill>
-          </a:ln>
-        </p:spPr>
-        <p:txBody>
-          <a:bodyPr wrap="square" rtlCol="0">
-            <a:spAutoFit/>
-          </a:bodyPr>
-          <a:lstStyle/>
-          <a:p>
-            <a:r>
-              <a:rPr lang="en-GB" dirty="0"/>
-              <a:t>A</a:t>
-            </a:r>
-            <a:r>
-              <a:rPr lang="en-IT" dirty="0"/>
-              <a:t>ctivity_6=</a:t>
-            </a:r>
-            <a:r>
-              <a:rPr lang="en-GB" dirty="0" err="1"/>
-              <a:t>Estabelecimento</a:t>
-            </a:r>
-            <a:r>
-              <a:rPr lang="en-GB" dirty="0"/>
-              <a:t> e </a:t>
-            </a:r>
-            <a:r>
-              <a:rPr lang="en-GB" dirty="0" err="1"/>
-              <a:t>Fiscalização</a:t>
-            </a:r>
-            <a:r>
-              <a:rPr lang="en-GB" dirty="0"/>
-              <a:t> de </a:t>
-            </a:r>
-            <a:r>
-              <a:rPr lang="en-GB" dirty="0" err="1"/>
-              <a:t>Áreas</a:t>
-            </a:r>
-            <a:r>
-              <a:rPr lang="en-GB" dirty="0"/>
-              <a:t> </a:t>
-            </a:r>
-            <a:r>
-              <a:rPr lang="en-GB" dirty="0" err="1"/>
-              <a:t>Marinhas</a:t>
-            </a:r>
-            <a:r>
-              <a:rPr lang="en-GB" dirty="0"/>
-              <a:t> </a:t>
-            </a:r>
-            <a:r>
-              <a:rPr lang="en-GB" dirty="0" err="1"/>
-              <a:t>Protegidas</a:t>
-            </a:r>
-            <a:endParaRPr lang="en-IT" dirty="0"/>
-          </a:p>
-        </p:txBody>
-      </p:sp>
-      <p:sp>
-        <p:nvSpPr>
-          <p:cNvPr id="9" name="TextBox 8">
-            <a:extLst>
-              <a:ext uri="{FF2B5EF4-FFF2-40B4-BE49-F238E27FC236}">
-                <a16:creationId xmlns:a16="http://schemas.microsoft.com/office/drawing/2014/main" id="{64547B72-4548-C34E-50F9-88A51308173A}"/>
-              </a:ext>
-            </a:extLst>
-          </p:cNvPr>
-          <p:cNvSpPr txBox="1"/>
-          <p:nvPr/>
-        </p:nvSpPr>
-        <p:spPr>
-          <a:xfrm>
-            <a:off x="6836735" y="3730199"/>
-            <a:ext cx="4380614" cy="646331"/>
-          </a:xfrm>
-          <a:prstGeom prst="rect">
-            <a:avLst/>
-          </a:prstGeom>
-          <a:solidFill>
-            <a:schemeClr val="bg1"/>
-          </a:solidFill>
-          <a:ln w="25400">
-            <a:solidFill>
-              <a:schemeClr val="accent5">
-                <a:lumMod val="60000"/>
-                <a:lumOff val="40000"/>
-              </a:schemeClr>
-            </a:solidFill>
-          </a:ln>
-        </p:spPr>
-        <p:txBody>
-          <a:bodyPr wrap="square" rtlCol="0">
-            <a:spAutoFit/>
-          </a:bodyPr>
-          <a:lstStyle/>
-          <a:p>
-            <a:r>
-              <a:rPr lang="en-GB" dirty="0"/>
-              <a:t>A</a:t>
-            </a:r>
-            <a:r>
-              <a:rPr lang="en-IT" dirty="0"/>
-              <a:t>ctivity_8=</a:t>
-            </a:r>
-            <a:r>
-              <a:rPr lang="en-GB" dirty="0" err="1"/>
-              <a:t>Estrutura</a:t>
-            </a:r>
-            <a:r>
-              <a:rPr lang="en-GB" dirty="0"/>
-              <a:t> </a:t>
-            </a:r>
-            <a:r>
-              <a:rPr lang="en-GB" dirty="0" err="1"/>
-              <a:t>regulatória</a:t>
-            </a:r>
-            <a:r>
-              <a:rPr lang="en-GB" dirty="0"/>
-              <a:t> para </a:t>
-            </a:r>
-            <a:r>
-              <a:rPr lang="en-GB" dirty="0" err="1"/>
-              <a:t>evitar</a:t>
-            </a:r>
-            <a:r>
-              <a:rPr lang="en-GB" dirty="0"/>
-              <a:t> a </a:t>
-            </a:r>
-            <a:r>
-              <a:rPr lang="en-GB" dirty="0" err="1"/>
-              <a:t>sobrepesca</a:t>
-            </a:r>
-            <a:endParaRPr lang="en-IT" dirty="0"/>
-          </a:p>
-        </p:txBody>
-      </p:sp>
-      <p:sp>
-        <p:nvSpPr>
-          <p:cNvPr id="10" name="TextBox 9">
-            <a:extLst>
-              <a:ext uri="{FF2B5EF4-FFF2-40B4-BE49-F238E27FC236}">
-                <a16:creationId xmlns:a16="http://schemas.microsoft.com/office/drawing/2014/main" id="{7DC8E486-B8C1-B042-A81D-4F8C98B48559}"/>
-              </a:ext>
-            </a:extLst>
-          </p:cNvPr>
-          <p:cNvSpPr txBox="1"/>
-          <p:nvPr/>
-        </p:nvSpPr>
-        <p:spPr>
-          <a:xfrm>
-            <a:off x="6836735" y="4677729"/>
-            <a:ext cx="4380614" cy="646331"/>
-          </a:xfrm>
-          <a:prstGeom prst="rect">
-            <a:avLst/>
-          </a:prstGeom>
-          <a:solidFill>
-            <a:schemeClr val="bg1"/>
-          </a:solidFill>
-          <a:ln w="25400">
-            <a:solidFill>
-              <a:schemeClr val="tx2">
-                <a:lumMod val="75000"/>
-                <a:lumOff val="25000"/>
-              </a:schemeClr>
-            </a:solidFill>
-          </a:ln>
-        </p:spPr>
-        <p:txBody>
-          <a:bodyPr wrap="square" rtlCol="0">
-            <a:spAutoFit/>
-          </a:bodyPr>
-          <a:lstStyle/>
-          <a:p>
-            <a:r>
-              <a:rPr lang="en-GB" dirty="0"/>
-              <a:t>A</a:t>
-            </a:r>
-            <a:r>
-              <a:rPr lang="en-IT" dirty="0"/>
-              <a:t>ctivity_3=</a:t>
-            </a:r>
-            <a:r>
-              <a:rPr lang="en-GB" dirty="0" err="1"/>
-              <a:t>Construção</a:t>
-            </a:r>
-            <a:r>
-              <a:rPr lang="en-GB" dirty="0"/>
-              <a:t> de </a:t>
-            </a:r>
-            <a:r>
-              <a:rPr lang="en-GB" dirty="0" err="1"/>
-              <a:t>uma</a:t>
-            </a:r>
-            <a:r>
-              <a:rPr lang="en-GB" dirty="0"/>
-              <a:t> </a:t>
-            </a:r>
-            <a:r>
-              <a:rPr lang="en-GB" dirty="0" err="1"/>
-              <a:t>oficina</a:t>
-            </a:r>
-            <a:r>
-              <a:rPr lang="en-GB" dirty="0"/>
-              <a:t> para </a:t>
-            </a:r>
-            <a:r>
-              <a:rPr lang="en-GB" dirty="0" err="1"/>
-              <a:t>barcos</a:t>
-            </a:r>
-            <a:r>
-              <a:rPr lang="en-GB" dirty="0"/>
-              <a:t> de </a:t>
-            </a:r>
-            <a:r>
-              <a:rPr lang="en-GB" dirty="0" err="1"/>
-              <a:t>pesca</a:t>
-            </a:r>
-            <a:endParaRPr lang="en-IT" dirty="0"/>
-          </a:p>
-        </p:txBody>
-      </p:sp>
-      <p:sp>
-        <p:nvSpPr>
-          <p:cNvPr id="11" name="TextBox 10">
-            <a:extLst>
-              <a:ext uri="{FF2B5EF4-FFF2-40B4-BE49-F238E27FC236}">
-                <a16:creationId xmlns:a16="http://schemas.microsoft.com/office/drawing/2014/main" id="{EEE0DB2E-6897-0E46-9C51-57A7AE1D310F}"/>
-              </a:ext>
-            </a:extLst>
-          </p:cNvPr>
-          <p:cNvSpPr txBox="1"/>
-          <p:nvPr/>
-        </p:nvSpPr>
-        <p:spPr>
-          <a:xfrm>
-            <a:off x="6836735" y="5625259"/>
-            <a:ext cx="4380614" cy="923330"/>
-          </a:xfrm>
-          <a:prstGeom prst="rect">
-            <a:avLst/>
-          </a:prstGeom>
-          <a:solidFill>
-            <a:schemeClr val="bg1"/>
-          </a:solidFill>
-          <a:ln w="25400">
-            <a:solidFill>
-              <a:schemeClr val="tx2">
-                <a:lumMod val="75000"/>
-                <a:lumOff val="25000"/>
-              </a:schemeClr>
-            </a:solidFill>
-          </a:ln>
-        </p:spPr>
-        <p:txBody>
-          <a:bodyPr wrap="square" rtlCol="0">
-            <a:spAutoFit/>
-          </a:bodyPr>
-          <a:lstStyle/>
-          <a:p>
-            <a:r>
-              <a:rPr lang="en-GB" dirty="0"/>
-              <a:t>A</a:t>
-            </a:r>
-            <a:r>
-              <a:rPr lang="en-IT" dirty="0"/>
-              <a:t>ctivity_2=</a:t>
-            </a:r>
-            <a:r>
-              <a:rPr lang="en-GB" dirty="0" err="1"/>
-              <a:t>Construção</a:t>
-            </a:r>
-            <a:r>
-              <a:rPr lang="en-GB" dirty="0"/>
-              <a:t> de mercados </a:t>
-            </a:r>
-            <a:r>
-              <a:rPr lang="en-GB" dirty="0" err="1"/>
-              <a:t>varejistas</a:t>
-            </a:r>
-            <a:r>
-              <a:rPr lang="en-GB" dirty="0"/>
-              <a:t> com </a:t>
-            </a:r>
-            <a:r>
-              <a:rPr lang="en-GB" dirty="0" err="1"/>
-              <a:t>armazenamento</a:t>
-            </a:r>
-            <a:r>
-              <a:rPr lang="en-GB" dirty="0"/>
-              <a:t> </a:t>
-            </a:r>
-            <a:r>
-              <a:rPr lang="en-GB" dirty="0" err="1"/>
-              <a:t>refrigerado</a:t>
-            </a:r>
-            <a:r>
-              <a:rPr lang="en-GB" dirty="0"/>
-              <a:t> e </a:t>
-            </a:r>
-            <a:r>
-              <a:rPr lang="en-GB" dirty="0" err="1"/>
-              <a:t>higiene</a:t>
-            </a:r>
-            <a:r>
-              <a:rPr lang="en-GB" dirty="0"/>
-              <a:t> de </a:t>
-            </a:r>
-            <a:r>
-              <a:rPr lang="en-GB" dirty="0" err="1"/>
-              <a:t>preparação</a:t>
-            </a:r>
-            <a:endParaRPr lang="en-IT" dirty="0"/>
-          </a:p>
-        </p:txBody>
-      </p:sp>
-      <p:sp>
-        <p:nvSpPr>
-          <p:cNvPr id="12" name="TextBox 11">
-            <a:extLst>
-              <a:ext uri="{FF2B5EF4-FFF2-40B4-BE49-F238E27FC236}">
-                <a16:creationId xmlns:a16="http://schemas.microsoft.com/office/drawing/2014/main" id="{8304D80A-A3EE-018E-CE70-8BF2931DA6E9}"/>
-              </a:ext>
-            </a:extLst>
-          </p:cNvPr>
-          <p:cNvSpPr txBox="1"/>
-          <p:nvPr/>
-        </p:nvSpPr>
-        <p:spPr>
-          <a:xfrm>
-            <a:off x="5791200" y="1034150"/>
-            <a:ext cx="808381" cy="584775"/>
-          </a:xfrm>
-          <a:prstGeom prst="rect">
-            <a:avLst/>
-          </a:prstGeom>
-          <a:noFill/>
-        </p:spPr>
-        <p:txBody>
-          <a:bodyPr wrap="square" rtlCol="0">
-            <a:spAutoFit/>
-          </a:bodyPr>
-          <a:lstStyle/>
-          <a:p>
-            <a:r>
-              <a:rPr lang="en-IT" sz="3200" dirty="0"/>
-              <a:t>*</a:t>
-            </a:r>
-          </a:p>
-        </p:txBody>
-      </p:sp>
-      <p:sp>
-        <p:nvSpPr>
           <p:cNvPr id="13" name="TextBox 12">
             <a:extLst>
               <a:ext uri="{FF2B5EF4-FFF2-40B4-BE49-F238E27FC236}">
@@ -5588,76 +4565,6 @@
         <p:spPr>
           <a:xfrm>
             <a:off x="4982819" y="4979214"/>
-            <a:ext cx="808381" cy="584775"/>
-          </a:xfrm>
-          <a:prstGeom prst="rect">
-            <a:avLst/>
-          </a:prstGeom>
-          <a:noFill/>
-        </p:spPr>
-        <p:txBody>
-          <a:bodyPr wrap="square" rtlCol="0">
-            <a:spAutoFit/>
-          </a:bodyPr>
-          <a:lstStyle/>
-          <a:p>
-            <a:r>
-              <a:rPr lang="en-IT" sz="3200" dirty="0"/>
-              <a:t>*</a:t>
-            </a:r>
-          </a:p>
-        </p:txBody>
-      </p:sp>
-      <p:sp>
-        <p:nvSpPr>
-          <p:cNvPr id="14" name="TextBox 13">
-            <a:extLst>
-              <a:ext uri="{FF2B5EF4-FFF2-40B4-BE49-F238E27FC236}">
-                <a16:creationId xmlns:a16="http://schemas.microsoft.com/office/drawing/2014/main" id="{32DF04FA-A9DF-FD3B-BD11-387270063E10}"/>
-              </a:ext>
-            </a:extLst>
-          </p:cNvPr>
-          <p:cNvSpPr txBox="1"/>
-          <p:nvPr/>
-        </p:nvSpPr>
-        <p:spPr>
-          <a:xfrm>
-            <a:off x="5657986" y="1987659"/>
-            <a:ext cx="808381" cy="584775"/>
-          </a:xfrm>
-          <a:prstGeom prst="rect">
-            <a:avLst/>
-          </a:prstGeom>
-          <a:noFill/>
-        </p:spPr>
-        <p:txBody>
-          <a:bodyPr wrap="square" rtlCol="0">
-            <a:spAutoFit/>
-          </a:bodyPr>
-          <a:lstStyle/>
-          <a:p>
-            <a:r>
-              <a:rPr lang="en-IT" sz="3200" dirty="0"/>
-              <a:t>*</a:t>
-            </a:r>
-          </a:p>
-        </p:txBody>
-      </p:sp>
-      <p:sp>
-        <p:nvSpPr>
-          <p:cNvPr id="15" name="TextBox 14">
-            <a:extLst>
-              <a:ext uri="{FF2B5EF4-FFF2-40B4-BE49-F238E27FC236}">
-                <a16:creationId xmlns:a16="http://schemas.microsoft.com/office/drawing/2014/main" id="{6CD81F71-33AB-2884-8A28-49FD4A505AA6}"/>
-              </a:ext>
-            </a:extLst>
-          </p:cNvPr>
-          <p:cNvSpPr txBox="1"/>
-          <p:nvPr/>
-        </p:nvSpPr>
-        <p:spPr>
-          <a:xfrm>
-            <a:off x="5657985" y="2421503"/>
             <a:ext cx="808381" cy="584775"/>
           </a:xfrm>
           <a:prstGeom prst="rect">
@@ -5708,6 +4615,144 @@
           </a:prstGeom>
         </p:spPr>
       </p:pic>
+      <p:sp>
+        <p:nvSpPr>
+          <p:cNvPr id="2" name="TextBox 1">
+            <a:extLst>
+              <a:ext uri="{FF2B5EF4-FFF2-40B4-BE49-F238E27FC236}">
+                <a16:creationId xmlns:a16="http://schemas.microsoft.com/office/drawing/2014/main" id="{48389583-441A-7546-8845-CC07A2E77E98}"/>
+              </a:ext>
+            </a:extLst>
+          </p:cNvPr>
+          <p:cNvSpPr txBox="1"/>
+          <p:nvPr/>
+        </p:nvSpPr>
+        <p:spPr>
+          <a:xfrm>
+            <a:off x="6753331" y="1987659"/>
+            <a:ext cx="5154789" cy="3970318"/>
+          </a:xfrm>
+          <a:prstGeom prst="rect">
+            <a:avLst/>
+          </a:prstGeom>
+          <a:noFill/>
+        </p:spPr>
+        <p:txBody>
+          <a:bodyPr wrap="square" rtlCol="0">
+            <a:spAutoFit/>
+          </a:bodyPr>
+          <a:lstStyle/>
+          <a:p>
+            <a:r>
+              <a:rPr lang="pt-BR" dirty="0"/>
+              <a:t>Sugestões mais populares:</a:t>
+            </a:r>
+          </a:p>
+          <a:p>
+            <a:pPr marL="342900" indent="-342900">
+              <a:buFont typeface="Arial" panose="020B0604020202020204" pitchFamily="34" charset="0"/>
+              <a:buChar char="•"/>
+            </a:pPr>
+            <a:r>
+              <a:rPr lang="pt-BR" dirty="0"/>
+              <a:t>Desenvolvimento e fiscalização de áreas marinhas protegidas</a:t>
+            </a:r>
+          </a:p>
+          <a:p>
+            <a:pPr marL="342900" indent="-342900">
+              <a:buFont typeface="Arial" panose="020B0604020202020204" pitchFamily="34" charset="0"/>
+              <a:buChar char="•"/>
+            </a:pPr>
+            <a:r>
+              <a:rPr lang="pt-BR" dirty="0"/>
+              <a:t>Construção de mercados de retalho com armazenamento refrigerado e regras de higiene de preparação </a:t>
+            </a:r>
+          </a:p>
+          <a:p>
+            <a:pPr marL="342900" indent="-342900">
+              <a:buFont typeface="Arial" panose="020B0604020202020204" pitchFamily="34" charset="0"/>
+              <a:buChar char="•"/>
+            </a:pPr>
+            <a:r>
+              <a:rPr lang="pt-BR" dirty="0"/>
+              <a:t>Criar zonas de expansão seguras para comunidades costeiras.</a:t>
+            </a:r>
+          </a:p>
+          <a:p>
+            <a:endParaRPr lang="pt-BR" dirty="0"/>
+          </a:p>
+          <a:p>
+            <a:r>
+              <a:rPr lang="pt-BR" dirty="0"/>
+              <a:t>Menos popular:</a:t>
+            </a:r>
+          </a:p>
+          <a:p>
+            <a:pPr marL="342900" indent="-342900">
+              <a:buFont typeface="Arial" panose="020B0604020202020204" pitchFamily="34" charset="0"/>
+              <a:buChar char="•"/>
+            </a:pPr>
+            <a:r>
+              <a:rPr lang="pt-BR" dirty="0"/>
+              <a:t>Dragagem de areia para reparar praias erodidas </a:t>
+            </a:r>
+          </a:p>
+          <a:p>
+            <a:pPr marL="342900" indent="-342900">
+              <a:buFont typeface="Arial" panose="020B0604020202020204" pitchFamily="34" charset="0"/>
+              <a:buChar char="•"/>
+            </a:pPr>
+            <a:r>
+              <a:rPr lang="pt-BR" dirty="0"/>
+              <a:t>Uso responsável de dispositivos de agregação de peixes ancorados (FADs).</a:t>
+            </a:r>
+            <a:endParaRPr lang="en-GB" dirty="0"/>
+          </a:p>
+        </p:txBody>
+      </p:sp>
+      <p:sp>
+        <p:nvSpPr>
+          <p:cNvPr id="4" name="TextBox 3">
+            <a:extLst>
+              <a:ext uri="{FF2B5EF4-FFF2-40B4-BE49-F238E27FC236}">
+                <a16:creationId xmlns:a16="http://schemas.microsoft.com/office/drawing/2014/main" id="{72E8F63F-CA30-8583-FA3E-AD131BF06E78}"/>
+              </a:ext>
+            </a:extLst>
+          </p:cNvPr>
+          <p:cNvSpPr txBox="1"/>
+          <p:nvPr/>
+        </p:nvSpPr>
+        <p:spPr>
+          <a:xfrm>
+            <a:off x="6753331" y="603262"/>
+            <a:ext cx="4742187" cy="923330"/>
+          </a:xfrm>
+          <a:prstGeom prst="rect">
+            <a:avLst/>
+          </a:prstGeom>
+          <a:noFill/>
+        </p:spPr>
+        <p:txBody>
+          <a:bodyPr wrap="square" rtlCol="0">
+            <a:spAutoFit/>
+          </a:bodyPr>
+          <a:lstStyle/>
+          <a:p>
+            <a:r>
+              <a:rPr lang="pt-BR" dirty="0"/>
+              <a:t>14/18 sugestões de adaptação &gt; média 4</a:t>
+            </a:r>
+          </a:p>
+          <a:p>
+            <a:r>
+              <a:rPr lang="pt-BR" dirty="0"/>
+              <a:t>
+Categoria mais popular: Defesas costeiras</a:t>
+            </a:r>
+            <a:endParaRPr lang="en-GB" dirty="0"/>
+          </a:p>
+        </p:txBody>
+      </p:sp>
     </p:spTree>
     <p:extLst>
       <p:ext uri="{BB962C8B-B14F-4D97-AF65-F5344CB8AC3E}">

</xml_diff>